<commit_message>
Add opt-in Replit deployment with protected account initialization
</commit_message>
<xml_diff>
--- a/submission/Pitch_Deck_EzQuote.pptx
+++ b/submission/Pitch_Deck_EzQuote.pptx
@@ -9706,7 +9706,7 @@
                 </a:solidFill>
                 <a:latin typeface="DejaVu Sans"/>
               </a:rPr>
-              <a:t>331</a:t>
+              <a:t>352</a:t>
             </a:r>
           </a:p>
         </p:txBody>
@@ -10479,7 +10479,7 @@
                 </a:solidFill>
                 <a:latin typeface="DejaVu Sans"/>
               </a:rPr>
-              <a:t>Quantity integrity, multilingual rules, stock and pricing limits, permissions, corrections, review binding,</a:t>
+              <a:t>Quantity integrity, multilingual rules, stock and pricing limits, permissions, review binding, approvals,</a:t>
             </a:r>
           </a:p>
           <a:p>
@@ -10501,7 +10501,7 @@
                 </a:solidFill>
                 <a:latin typeface="DejaVu Sans"/>
               </a:rPr>
-              <a:t>owner approval, PDF / Excel, customer outcomes and isolated mobile links.</a:t>
+              <a:t>exports, outcomes, mobile links, and opt-in hosting origins and account initialization.</a:t>
             </a:r>
           </a:p>
         </p:txBody>

</xml_diff>

<commit_message>
Add team proposal and update submission materials
</commit_message>
<xml_diff>
--- a/submission/Pitch_Deck_EzQuote.pptx
+++ b/submission/Pitch_Deck_EzQuote.pptx
@@ -3186,7 +3186,7 @@
                 </a:solidFill>
                 <a:latin typeface="DejaVu Sans"/>
               </a:rPr>
-              <a:t>EZQUOTE  /  SDC 2026</a:t>
+              <a:t>EZQUOTE  /  TEAM LULU MASTER  /  SDC 2026</a:t>
             </a:r>
           </a:p>
         </p:txBody>
@@ -12839,7 +12839,29 @@
                 </a:solidFill>
                 <a:latin typeface="DejaVu Sans"/>
               </a:rPr>
-              <a:t>Official form, eligibility and signatures require team input.</a:t>
+              <a:t>Signed proposal supplied; phone/provider details still need</a:t>
+            </a:r>
+          </a:p>
+          <a:p>
+            <a:pPr>
+              <a:lnSpc>
+                <a:spcPct val="115000"/>
+              </a:lnSpc>
+              <a:spcBef>
+                <a:spcPts val="0"/>
+              </a:spcBef>
+              <a:spcAft>
+                <a:spcPts val="0"/>
+              </a:spcAft>
+            </a:pPr>
+            <a:r>
+              <a:rPr sz="1210" b="0">
+                <a:solidFill>
+                  <a:srgbClr val="527064"/>
+                </a:solidFill>
+                <a:latin typeface="DejaVu Sans"/>
+              </a:rPr>
+              <a:t>review.</a:t>
             </a:r>
           </a:p>
         </p:txBody>

</xml_diff>